<commit_message>
updating ppt and class agenda
</commit_message>
<xml_diff>
--- a/docs/lectures/in-class_activities/class_10.pptx
+++ b/docs/lectures/in-class_activities/class_10.pptx
@@ -10,14 +10,14 @@
   <p:sldIdLst>
     <p:sldId id="480" r:id="rId2"/>
     <p:sldId id="712" r:id="rId3"/>
-    <p:sldId id="1549" r:id="rId4"/>
+    <p:sldId id="1554" r:id="rId4"/>
     <p:sldId id="1551" r:id="rId5"/>
     <p:sldId id="723" r:id="rId6"/>
     <p:sldId id="1552" r:id="rId7"/>
     <p:sldId id="1553" r:id="rId8"/>
-    <p:sldId id="1548" r:id="rId9"/>
+    <p:sldId id="1555" r:id="rId9"/>
     <p:sldId id="714" r:id="rId10"/>
-    <p:sldId id="675" r:id="rId11"/>
+    <p:sldId id="1556" r:id="rId11"/>
     <p:sldId id="1547" r:id="rId12"/>
   </p:sldIdLst>
   <p:sldSz cx="12192000" cy="6858000"/>
@@ -207,7 +207,7 @@
           <a:p>
             <a:fld id="{6AC7DB66-C6D6-B24E-B345-FA3772C924EA}" type="datetimeFigureOut">
               <a:rPr lang="en-US" smtClean="0"/>
-              <a:t>10/20/21</a:t>
+              <a:t>10/20/25</a:t>
             </a:fld>
             <a:endParaRPr lang="en-US"/>
           </a:p>
@@ -602,24 +602,18 @@
           <a:bodyPr/>
           <a:lstStyle/>
           <a:p>
-            <a:endParaRPr lang="en-US" dirty="0"/>
-          </a:p>
-          <a:p>
-            <a:r>
-              <a:rPr lang="en-US" dirty="0"/>
-              <a:t>Changes in any attribute of a population over time. </a:t>
-            </a:r>
-          </a:p>
-          <a:p>
-            <a:r>
-              <a:rPr lang="en-US" dirty="0"/>
-              <a:t>Evolutionary</a:t>
-            </a:r>
-            <a:r>
-              <a:rPr lang="en-US" baseline="0" dirty="0"/>
-              <a:t> change leads to adaptation and must involve a change in the frequency of individual genes in a population from generation to generation.</a:t>
-            </a:r>
-            <a:endParaRPr lang="en-US" dirty="0"/>
+            <a:r>
+              <a:rPr lang="en-US"/>
+              <a:t>Do not modify the notes in this section to avoid tampering with the Poll Everywhere activity.
+More info at polleverywhere.com/support
+Trichuris trichiura doesn't take that much blood from its host, but its pathology can be severe nonetheless, due to the damage it causes to the intestinal epithelium. Why is damage to the intestinal epithelium bad? List as many reasons as you can.</a:t>
+            </a:r>
+          </a:p>
+          <a:p>
+            <a:r>
+              <a:rPr lang="en-US"/>
+              <a:t>https://www.polleverywhere.com/discourses/r3QPrLFthhjdUo0RhoMMF</a:t>
+            </a:r>
           </a:p>
         </p:txBody>
       </p:sp>
@@ -630,22 +624,16 @@
             <a:spLocks noGrp="1"/>
           </p:cNvSpPr>
           <p:nvPr>
-            <p:ph type="sldNum" sz="quarter" idx="10"/>
-          </p:nvPr>
-        </p:nvSpPr>
-        <p:spPr/>
-        <p:txBody>
-          <a:bodyPr/>
-          <a:lstStyle/>
-          <a:p>
-            <a:pPr>
-              <a:defRPr/>
-            </a:pPr>
-            <a:fld id="{217FB9E2-7C0C-AB45-B0B4-06C6B1BD2B82}" type="slidenum">
+            <p:ph type="sldNum" sz="quarter" idx="5"/>
+          </p:nvPr>
+        </p:nvSpPr>
+        <p:spPr/>
+        <p:txBody>
+          <a:bodyPr/>
+          <a:lstStyle/>
+          <a:p>
+            <a:fld id="{4218707C-A528-5347-B512-111D9A72273A}" type="slidenum">
               <a:rPr lang="en-US" smtClean="0"/>
-              <a:pPr>
-                <a:defRPr/>
-              </a:pPr>
               <a:t>10</a:t>
             </a:fld>
             <a:endParaRPr lang="en-US"/>
@@ -655,7 +643,7 @@
     </p:spTree>
     <p:extLst>
       <p:ext uri="{BB962C8B-B14F-4D97-AF65-F5344CB8AC3E}">
-        <p14:creationId xmlns:p14="http://schemas.microsoft.com/office/powerpoint/2010/main" val="71014221"/>
+        <p14:creationId xmlns:p14="http://schemas.microsoft.com/office/powerpoint/2010/main" val="1794573240"/>
       </p:ext>
     </p:extLst>
   </p:cSld>
@@ -879,13 +867,15 @@
           <a:p>
             <a:r>
               <a:rPr lang="en-US"/>
-              <a:t>The geohelminths have been co-evolving with humans for a long, long time. What are some cultural practices that might have arisen because they protect human populations against geohelminth infection?</a:t>
-            </a:r>
-          </a:p>
-          <a:p>
-            <a:r>
-              <a:rPr lang="en-US"/>
-              <a:t>https://www.polleverywhere.com/discourses/4txOezA5bPCKs28stVXCK</a:t>
+              <a:t>Do not modify the notes in this section to avoid tampering with the Poll Everywhere activity.
+More info at polleverywhere.com/support
+The geohelminths have been co-evolving with humans for a long, long time. What are some cultural practices that might have arisen because they protect human populations against geohelminth infection?</a:t>
+            </a:r>
+          </a:p>
+          <a:p>
+            <a:r>
+              <a:rPr lang="en-US"/>
+              <a:t>https://www.polleverywhere.com/discourses/LTuvUnJLBJFADVdDdLxTI</a:t>
             </a:r>
           </a:p>
         </p:txBody>
@@ -916,7 +906,7 @@
     </p:spTree>
     <p:extLst>
       <p:ext uri="{BB962C8B-B14F-4D97-AF65-F5344CB8AC3E}">
-        <p14:creationId xmlns:p14="http://schemas.microsoft.com/office/powerpoint/2010/main" val="2439871992"/>
+        <p14:creationId xmlns:p14="http://schemas.microsoft.com/office/powerpoint/2010/main" val="958960532"/>
       </p:ext>
     </p:extLst>
   </p:cSld>
@@ -1308,13 +1298,15 @@
           <a:p>
             <a:r>
               <a:rPr lang="en-US"/>
-              <a:t>Ascaris eggs are tough because of their thick mammilated layer. What are some of the conditions that Ascaris eggs can survive that might kill other parasite eggs?</a:t>
-            </a:r>
-          </a:p>
-          <a:p>
-            <a:r>
-              <a:rPr lang="en-US"/>
-              <a:t>https://www.polleverywhere.com/free_text_polls/QZcnVvoAIKBGctyctG1KM</a:t>
+              <a:t>Do not modify the notes in this section to avoid tampering with the Poll Everywhere activity.
+More info at polleverywhere.com/support
+Ascaris eggs are tough because of their thick mammilated layer. What are some of the conditions that Ascaris eggs can survive that might kill other parasite eggs?</a:t>
+            </a:r>
+          </a:p>
+          <a:p>
+            <a:r>
+              <a:rPr lang="en-US"/>
+              <a:t>https://www.polleverywhere.com/free_text_polls/mgHRf1ghW7CBPpWzHrX9X</a:t>
             </a:r>
           </a:p>
         </p:txBody>
@@ -1345,7 +1337,7 @@
     </p:spTree>
     <p:extLst>
       <p:ext uri="{BB962C8B-B14F-4D97-AF65-F5344CB8AC3E}">
-        <p14:creationId xmlns:p14="http://schemas.microsoft.com/office/powerpoint/2010/main" val="1032219516"/>
+        <p14:creationId xmlns:p14="http://schemas.microsoft.com/office/powerpoint/2010/main" val="1401896628"/>
       </p:ext>
     </p:extLst>
   </p:cSld>
@@ -1586,7 +1578,7 @@
           <a:p>
             <a:fld id="{21DDE3A9-9D48-7D40-AF95-520AE186EA5D}" type="datetimeFigureOut">
               <a:rPr lang="en-US" smtClean="0"/>
-              <a:t>10/20/21</a:t>
+              <a:t>10/20/25</a:t>
             </a:fld>
             <a:endParaRPr lang="en-US"/>
           </a:p>
@@ -1784,7 +1776,7 @@
           <a:p>
             <a:fld id="{21DDE3A9-9D48-7D40-AF95-520AE186EA5D}" type="datetimeFigureOut">
               <a:rPr lang="en-US" smtClean="0"/>
-              <a:t>10/20/21</a:t>
+              <a:t>10/20/25</a:t>
             </a:fld>
             <a:endParaRPr lang="en-US"/>
           </a:p>
@@ -1992,7 +1984,7 @@
           <a:p>
             <a:fld id="{21DDE3A9-9D48-7D40-AF95-520AE186EA5D}" type="datetimeFigureOut">
               <a:rPr lang="en-US" smtClean="0"/>
-              <a:t>10/20/21</a:t>
+              <a:t>10/20/25</a:t>
             </a:fld>
             <a:endParaRPr lang="en-US"/>
           </a:p>
@@ -2190,7 +2182,7 @@
           <a:p>
             <a:fld id="{21DDE3A9-9D48-7D40-AF95-520AE186EA5D}" type="datetimeFigureOut">
               <a:rPr lang="en-US" smtClean="0"/>
-              <a:t>10/20/21</a:t>
+              <a:t>10/20/25</a:t>
             </a:fld>
             <a:endParaRPr lang="en-US"/>
           </a:p>
@@ -2465,7 +2457,7 @@
           <a:p>
             <a:fld id="{21DDE3A9-9D48-7D40-AF95-520AE186EA5D}" type="datetimeFigureOut">
               <a:rPr lang="en-US" smtClean="0"/>
-              <a:t>10/20/21</a:t>
+              <a:t>10/20/25</a:t>
             </a:fld>
             <a:endParaRPr lang="en-US"/>
           </a:p>
@@ -2730,7 +2722,7 @@
           <a:p>
             <a:fld id="{21DDE3A9-9D48-7D40-AF95-520AE186EA5D}" type="datetimeFigureOut">
               <a:rPr lang="en-US" smtClean="0"/>
-              <a:t>10/20/21</a:t>
+              <a:t>10/20/25</a:t>
             </a:fld>
             <a:endParaRPr lang="en-US"/>
           </a:p>
@@ -3142,7 +3134,7 @@
           <a:p>
             <a:fld id="{21DDE3A9-9D48-7D40-AF95-520AE186EA5D}" type="datetimeFigureOut">
               <a:rPr lang="en-US" smtClean="0"/>
-              <a:t>10/20/21</a:t>
+              <a:t>10/20/25</a:t>
             </a:fld>
             <a:endParaRPr lang="en-US"/>
           </a:p>
@@ -3283,7 +3275,7 @@
           <a:p>
             <a:fld id="{21DDE3A9-9D48-7D40-AF95-520AE186EA5D}" type="datetimeFigureOut">
               <a:rPr lang="en-US" smtClean="0"/>
-              <a:t>10/20/21</a:t>
+              <a:t>10/20/25</a:t>
             </a:fld>
             <a:endParaRPr lang="en-US"/>
           </a:p>
@@ -3396,7 +3388,7 @@
           <a:p>
             <a:fld id="{21DDE3A9-9D48-7D40-AF95-520AE186EA5D}" type="datetimeFigureOut">
               <a:rPr lang="en-US" smtClean="0"/>
-              <a:t>10/20/21</a:t>
+              <a:t>10/20/25</a:t>
             </a:fld>
             <a:endParaRPr lang="en-US"/>
           </a:p>
@@ -3707,7 +3699,7 @@
           <a:p>
             <a:fld id="{21DDE3A9-9D48-7D40-AF95-520AE186EA5D}" type="datetimeFigureOut">
               <a:rPr lang="en-US" smtClean="0"/>
-              <a:t>10/20/21</a:t>
+              <a:t>10/20/25</a:t>
             </a:fld>
             <a:endParaRPr lang="en-US"/>
           </a:p>
@@ -3995,7 +3987,7 @@
           <a:p>
             <a:fld id="{21DDE3A9-9D48-7D40-AF95-520AE186EA5D}" type="datetimeFigureOut">
               <a:rPr lang="en-US" smtClean="0"/>
-              <a:t>10/20/21</a:t>
+              <a:t>10/20/25</a:t>
             </a:fld>
             <a:endParaRPr lang="en-US"/>
           </a:p>
@@ -4236,7 +4228,7 @@
           <a:p>
             <a:fld id="{21DDE3A9-9D48-7D40-AF95-520AE186EA5D}" type="datetimeFigureOut">
               <a:rPr lang="en-US" smtClean="0"/>
-              <a:t>10/20/21</a:t>
+              <a:t>10/20/25</a:t>
             </a:fld>
             <a:endParaRPr lang="en-US"/>
           </a:p>
@@ -4705,7 +4697,7 @@
                 <a:latin typeface="Avenir Book" panose="02000503020000020003" pitchFamily="2" charset="0"/>
                 <a:cs typeface="Avenir"/>
               </a:rPr>
-              <a:t>Practical session 10</a:t>
+              <a:t>Class 10</a:t>
             </a:r>
             <a:r>
               <a:rPr lang="en-US" sz="4800" dirty="0">
@@ -4762,107 +4754,90 @@
           <a:chExt cx="0" cy="0"/>
         </a:xfrm>
       </p:grpSpPr>
+      <p:sp>
+        <p:nvSpPr>
+          <p:cNvPr id="2" name="Title 1">
+            <a:extLst>
+              <a:ext uri="{FF2B5EF4-FFF2-40B4-BE49-F238E27FC236}">
+                <a16:creationId xmlns:a16="http://schemas.microsoft.com/office/drawing/2014/main" id="{BFF0D6C0-1717-781F-6C46-D441C1EE858C}"/>
+              </a:ext>
+            </a:extLst>
+          </p:cNvPr>
+          <p:cNvSpPr>
+            <a:spLocks noGrp="1"/>
+          </p:cNvSpPr>
+          <p:nvPr>
+            <p:ph type="ctrTitle"/>
+          </p:nvPr>
+        </p:nvSpPr>
+        <p:spPr/>
+        <p:txBody>
+          <a:bodyPr/>
+          <a:lstStyle/>
+          <a:p>
+            <a:endParaRPr lang="en-US"/>
+          </a:p>
+        </p:txBody>
+      </p:sp>
+      <p:sp>
+        <p:nvSpPr>
+          <p:cNvPr id="3" name="Subtitle 2">
+            <a:extLst>
+              <a:ext uri="{FF2B5EF4-FFF2-40B4-BE49-F238E27FC236}">
+                <a16:creationId xmlns:a16="http://schemas.microsoft.com/office/drawing/2014/main" id="{B9074499-3F70-3F89-7388-D9C1FD545391}"/>
+              </a:ext>
+            </a:extLst>
+          </p:cNvPr>
+          <p:cNvSpPr>
+            <a:spLocks noGrp="1"/>
+          </p:cNvSpPr>
+          <p:nvPr>
+            <p:ph type="subTitle" idx="1"/>
+          </p:nvPr>
+        </p:nvSpPr>
+        <p:spPr/>
+        <p:txBody>
+          <a:bodyPr/>
+          <a:lstStyle/>
+          <a:p>
+            <a:endParaRPr lang="en-US"/>
+          </a:p>
+        </p:txBody>
+      </p:sp>
       <p:pic>
         <p:nvPicPr>
-          <p:cNvPr id="5" name="Picture 4">
-            <a:extLst>
-              <a:ext uri="{FF2B5EF4-FFF2-40B4-BE49-F238E27FC236}">
-                <a16:creationId xmlns:a16="http://schemas.microsoft.com/office/drawing/2014/main" id="{C8F37AE3-B782-4641-8C9A-7A9115E2FD8D}"/>
+          <p:cNvPr id="5" name="slide.url=https://www.polleverywhere.com/discourses/r3QPrLFthhjdUo0RhoMMF">
+            <a:extLst>
+              <a:ext uri="{FF2B5EF4-FFF2-40B4-BE49-F238E27FC236}">
+                <a16:creationId xmlns:a16="http://schemas.microsoft.com/office/drawing/2014/main" id="{573833A8-B65A-B86E-38D9-74B4ECB455AB}"/>
               </a:ext>
             </a:extLst>
           </p:cNvPr>
           <p:cNvPicPr>
-            <a:picLocks noChangeAspect="1"/>
+            <a:picLocks/>
           </p:cNvPicPr>
           <p:nvPr/>
         </p:nvPicPr>
-        <p:blipFill rotWithShape="1">
+        <p:blipFill>
           <a:blip r:embed="rId3"/>
-          <a:srcRect l="6978" t="6285" r="7095" b="7757"/>
-          <a:stretch/>
+          <a:stretch>
+            <a:fillRect/>
+          </a:stretch>
         </p:blipFill>
         <p:spPr>
           <a:xfrm>
-            <a:off x="1128713" y="128588"/>
-            <a:ext cx="9929812" cy="6615541"/>
+            <a:off x="63500" y="63500"/>
+            <a:ext cx="12065000" cy="6731000"/>
           </a:xfrm>
           <a:prstGeom prst="rect">
             <a:avLst/>
           </a:prstGeom>
         </p:spPr>
       </p:pic>
-      <p:sp>
-        <p:nvSpPr>
-          <p:cNvPr id="4" name="Rectangle 3">
-            <a:extLst>
-              <a:ext uri="{FF2B5EF4-FFF2-40B4-BE49-F238E27FC236}">
-                <a16:creationId xmlns:a16="http://schemas.microsoft.com/office/drawing/2014/main" id="{502CF663-8301-A549-A557-61D703DD4559}"/>
-              </a:ext>
-            </a:extLst>
-          </p:cNvPr>
-          <p:cNvSpPr>
-            <a:spLocks noChangeArrowheads="1"/>
-          </p:cNvSpPr>
-          <p:nvPr/>
-        </p:nvSpPr>
-        <p:spPr bwMode="auto">
-          <a:xfrm>
-            <a:off x="271470" y="394961"/>
-            <a:ext cx="11649060" cy="630942"/>
-          </a:xfrm>
-          <a:prstGeom prst="rect">
-            <a:avLst/>
-          </a:prstGeom>
-          <a:noFill/>
-          <a:ln w="9525">
-            <a:noFill/>
-            <a:miter lim="800000"/>
-            <a:headEnd/>
-            <a:tailEnd/>
-          </a:ln>
-          <a:effectLst/>
-        </p:spPr>
-        <p:txBody>
-          <a:bodyPr wrap="square">
-            <a:spAutoFit/>
-          </a:bodyPr>
-          <a:lstStyle/>
-          <a:p>
-            <a:pPr algn="ctr">
-              <a:defRPr/>
-            </a:pPr>
-            <a:r>
-              <a:rPr lang="en-US" sz="3500" b="1" dirty="0">
-                <a:latin typeface="Avenir"/>
-                <a:cs typeface="Avenir"/>
-              </a:rPr>
-              <a:t>Q4. pathology of </a:t>
-            </a:r>
-            <a:r>
-              <a:rPr lang="en-US" sz="3500" b="1" i="1" dirty="0">
-                <a:latin typeface="Avenir"/>
-                <a:cs typeface="Avenir"/>
-              </a:rPr>
-              <a:t>Trichuris </a:t>
-            </a:r>
-            <a:r>
-              <a:rPr lang="en-US" sz="3500" b="1" i="1" dirty="0" err="1">
-                <a:latin typeface="Avenir"/>
-                <a:cs typeface="Avenir"/>
-              </a:rPr>
-              <a:t>trichiura</a:t>
-            </a:r>
-            <a:endParaRPr lang="en-US" sz="3500" b="1" i="1" dirty="0">
-              <a:latin typeface="Avenir"/>
-              <a:cs typeface="Avenir"/>
-            </a:endParaRPr>
-          </a:p>
-        </p:txBody>
-      </p:sp>
     </p:spTree>
     <p:extLst>
       <p:ext uri="{BB962C8B-B14F-4D97-AF65-F5344CB8AC3E}">
-        <p14:creationId xmlns:p14="http://schemas.microsoft.com/office/powerpoint/2010/main" val="1217805624"/>
+        <p14:creationId xmlns:p14="http://schemas.microsoft.com/office/powerpoint/2010/main" val="671798743"/>
       </p:ext>
     </p:extLst>
   </p:cSld>
@@ -4941,7 +4916,7 @@
                 <a:latin typeface="Avenir Book" panose="02000503020000020003" pitchFamily="2" charset="0"/>
                 <a:cs typeface="Avenir"/>
               </a:rPr>
-              <a:t>Practical session 10</a:t>
+              <a:t>Class 10</a:t>
             </a:r>
             <a:r>
               <a:rPr lang="en-US" sz="4800" dirty="0">
@@ -5107,7 +5082,7 @@
           <p:cNvPr id="2" name="Title 1">
             <a:extLst>
               <a:ext uri="{FF2B5EF4-FFF2-40B4-BE49-F238E27FC236}">
-                <a16:creationId xmlns:a16="http://schemas.microsoft.com/office/drawing/2014/main" id="{41027014-9CB8-8E45-8C4D-65E2A6CD1AFE}"/>
+                <a16:creationId xmlns:a16="http://schemas.microsoft.com/office/drawing/2014/main" id="{F79A49C1-E4A5-7FB9-A553-B171F9E724C0}"/>
               </a:ext>
             </a:extLst>
           </p:cNvPr>
@@ -5132,7 +5107,7 @@
           <p:cNvPr id="3" name="Subtitle 2">
             <a:extLst>
               <a:ext uri="{FF2B5EF4-FFF2-40B4-BE49-F238E27FC236}">
-                <a16:creationId xmlns:a16="http://schemas.microsoft.com/office/drawing/2014/main" id="{216E9B06-7137-FF47-B38B-E8B23E81F546}"/>
+                <a16:creationId xmlns:a16="http://schemas.microsoft.com/office/drawing/2014/main" id="{C7F079C3-9053-DEA6-6037-81EF018960D0}"/>
               </a:ext>
             </a:extLst>
           </p:cNvPr>
@@ -5154,10 +5129,10 @@
       </p:sp>
       <p:pic>
         <p:nvPicPr>
-          <p:cNvPr id="5" name="slide.url=https://www.polleverywhere.com/discourses/4txOezA5bPCKs28stVXCK">
-            <a:extLst>
-              <a:ext uri="{FF2B5EF4-FFF2-40B4-BE49-F238E27FC236}">
-                <a16:creationId xmlns:a16="http://schemas.microsoft.com/office/drawing/2014/main" id="{7DC50FBC-B56D-C442-B9E3-67E71A85B6E0}"/>
+          <p:cNvPr id="5" name="slide.url=https://www.polleverywhere.com/discourses/LTuvUnJLBJFADVdDdLxTI">
+            <a:extLst>
+              <a:ext uri="{FF2B5EF4-FFF2-40B4-BE49-F238E27FC236}">
+                <a16:creationId xmlns:a16="http://schemas.microsoft.com/office/drawing/2014/main" id="{89F561CD-08E8-D762-3484-EA9218E3916B}"/>
               </a:ext>
             </a:extLst>
           </p:cNvPr>
@@ -5185,7 +5160,7 @@
     </p:spTree>
     <p:extLst>
       <p:ext uri="{BB962C8B-B14F-4D97-AF65-F5344CB8AC3E}">
-        <p14:creationId xmlns:p14="http://schemas.microsoft.com/office/powerpoint/2010/main" val="3894735093"/>
+        <p14:creationId xmlns:p14="http://schemas.microsoft.com/office/powerpoint/2010/main" val="2269285094"/>
       </p:ext>
     </p:extLst>
   </p:cSld>
@@ -5346,7 +5321,7 @@
         <p:spPr bwMode="auto">
           <a:xfrm>
             <a:off x="5510761" y="1731842"/>
-            <a:ext cx="6139900" cy="2677656"/>
+            <a:ext cx="6139900" cy="3108543"/>
           </a:xfrm>
           <a:prstGeom prst="rect">
             <a:avLst/>
@@ -5388,7 +5363,7 @@
                 <a:latin typeface="Avenir"/>
                 <a:cs typeface="Avenir"/>
               </a:rPr>
-              <a:t>is counterintuitive in the extreme. Why on Earth does this intestinal parasite leave the intestine to make a long and pointless migration through the circulatory system?</a:t>
+              <a:t>is counterintuitive in the extreme. Why on Earth does this intestinal parasite leave the intestine to make a long and seemingly pointless migration through the circulatory system?</a:t>
             </a:r>
           </a:p>
         </p:txBody>
@@ -5438,7 +5413,7 @@
                 <a:latin typeface="Avenir"/>
                 <a:cs typeface="Avenir"/>
               </a:rPr>
-              <a:t>Ponder on your own (3 m), develop a plan with your group (5 m), then share with the class (5 m).</a:t>
+              <a:t>Ponder on your own (3 m), discuss with your group (5 m), then share with the class (5 m).</a:t>
             </a:r>
           </a:p>
         </p:txBody>
@@ -5892,7 +5867,7 @@
           <p:cNvPr id="2" name="Title 1">
             <a:extLst>
               <a:ext uri="{FF2B5EF4-FFF2-40B4-BE49-F238E27FC236}">
-                <a16:creationId xmlns:a16="http://schemas.microsoft.com/office/drawing/2014/main" id="{651A3AA2-3992-9144-A585-FF70DBA88C92}"/>
+                <a16:creationId xmlns:a16="http://schemas.microsoft.com/office/drawing/2014/main" id="{C86AA4C8-DA92-E7DB-9AAE-E2A094573933}"/>
               </a:ext>
             </a:extLst>
           </p:cNvPr>
@@ -5917,7 +5892,7 @@
           <p:cNvPr id="3" name="Subtitle 2">
             <a:extLst>
               <a:ext uri="{FF2B5EF4-FFF2-40B4-BE49-F238E27FC236}">
-                <a16:creationId xmlns:a16="http://schemas.microsoft.com/office/drawing/2014/main" id="{7BEBBBD5-5C1F-B947-B6CA-895DBD29A70D}"/>
+                <a16:creationId xmlns:a16="http://schemas.microsoft.com/office/drawing/2014/main" id="{859127AC-E8EC-F1D5-D41C-6D75ABC782D4}"/>
               </a:ext>
             </a:extLst>
           </p:cNvPr>
@@ -5939,10 +5914,10 @@
       </p:sp>
       <p:pic>
         <p:nvPicPr>
-          <p:cNvPr id="5" name="slide.url=https://www.polleverywhere.com/free_text_polls/QZcnVvoAIKBGctyctG1KM">
-            <a:extLst>
-              <a:ext uri="{FF2B5EF4-FFF2-40B4-BE49-F238E27FC236}">
-                <a16:creationId xmlns:a16="http://schemas.microsoft.com/office/drawing/2014/main" id="{F7795EF1-8C50-1140-8437-7DCFC31564FD}"/>
+          <p:cNvPr id="5" name="slide.url=https://www.polleverywhere.com/free_text_polls/mgHRf1ghW7CBPpWzHrX9X">
+            <a:extLst>
+              <a:ext uri="{FF2B5EF4-FFF2-40B4-BE49-F238E27FC236}">
+                <a16:creationId xmlns:a16="http://schemas.microsoft.com/office/drawing/2014/main" id="{3FECDCEB-3F56-BEAD-FE42-4C3FE8811ED1}"/>
               </a:ext>
             </a:extLst>
           </p:cNvPr>
@@ -5970,7 +5945,7 @@
     </p:spTree>
     <p:extLst>
       <p:ext uri="{BB962C8B-B14F-4D97-AF65-F5344CB8AC3E}">
-        <p14:creationId xmlns:p14="http://schemas.microsoft.com/office/powerpoint/2010/main" val="3079886231"/>
+        <p14:creationId xmlns:p14="http://schemas.microsoft.com/office/powerpoint/2010/main" val="3329413521"/>
       </p:ext>
     </p:extLst>
   </p:cSld>
@@ -6007,7 +5982,7 @@
         </p:nvSpPr>
         <p:spPr bwMode="auto">
           <a:xfrm>
-            <a:off x="271470" y="283451"/>
+            <a:off x="271470" y="592061"/>
             <a:ext cx="11649060" cy="630942"/>
           </a:xfrm>
           <a:prstGeom prst="rect">
@@ -6059,102 +6034,6 @@
           </a:p>
         </p:txBody>
       </p:sp>
-      <p:pic>
-        <p:nvPicPr>
-          <p:cNvPr id="6" name="Picture 5">
-            <a:extLst>
-              <a:ext uri="{FF2B5EF4-FFF2-40B4-BE49-F238E27FC236}">
-                <a16:creationId xmlns:a16="http://schemas.microsoft.com/office/drawing/2014/main" id="{24C76115-8B07-BF49-9DDC-5F3B697CE12E}"/>
-              </a:ext>
-            </a:extLst>
-          </p:cNvPr>
-          <p:cNvPicPr>
-            <a:picLocks noChangeAspect="1"/>
-          </p:cNvPicPr>
-          <p:nvPr/>
-        </p:nvPicPr>
-        <p:blipFill>
-          <a:blip r:embed="rId3">
-            <a:extLst>
-              <a:ext uri="{BEBA8EAE-BF5A-486C-A8C5-ECC9F3942E4B}">
-                <a14:imgProps xmlns:a14="http://schemas.microsoft.com/office/drawing/2010/main">
-                  <a14:imgLayer r:embed="rId4">
-                    <a14:imgEffect>
-                      <a14:backgroundRemoval t="9867" b="89867" l="6196" r="91630">
-                        <a14:foregroundMark x1="39022" y1="64000" x2="39022" y2="64000"/>
-                        <a14:foregroundMark x1="10000" y1="55200" x2="10000" y2="55200"/>
-                        <a14:foregroundMark x1="6304" y1="63467" x2="6304" y2="63467"/>
-                        <a14:foregroundMark x1="12935" y1="81067" x2="12935" y2="81067"/>
-                        <a14:foregroundMark x1="12500" y1="78933" x2="12500" y2="78933"/>
-                        <a14:foregroundMark x1="13152" y1="78933" x2="13152" y2="78933"/>
-                        <a14:foregroundMark x1="46413" y1="79467" x2="46413" y2="79467"/>
-                        <a14:foregroundMark x1="36630" y1="39200" x2="36630" y2="39200"/>
-                        <a14:foregroundMark x1="36630" y1="38667" x2="36630" y2="38667"/>
-                        <a14:foregroundMark x1="36630" y1="38400" x2="36630" y2="38400"/>
-                        <a14:foregroundMark x1="36630" y1="37867" x2="36630" y2="37867"/>
-                        <a14:foregroundMark x1="36630" y1="37867" x2="36630" y2="37867"/>
-                        <a14:foregroundMark x1="36630" y1="36800" x2="36630" y2="36800"/>
-                        <a14:foregroundMark x1="30109" y1="29067" x2="30109" y2="29067"/>
-                        <a14:foregroundMark x1="30326" y1="29067" x2="30326" y2="29067"/>
-                        <a14:foregroundMark x1="29891" y1="34667" x2="29891" y2="34667"/>
-                        <a14:foregroundMark x1="30109" y1="34667" x2="30109" y2="34667"/>
-                        <a14:foregroundMark x1="30543" y1="35733" x2="30543" y2="35733"/>
-                        <a14:foregroundMark x1="40326" y1="26400" x2="40326" y2="26400"/>
-                        <a14:foregroundMark x1="40761" y1="26400" x2="40761" y2="26400"/>
-                        <a14:foregroundMark x1="40761" y1="33067" x2="40761" y2="33067"/>
-                        <a14:foregroundMark x1="39891" y1="37333" x2="39891" y2="37333"/>
-                        <a14:foregroundMark x1="38261" y1="38667" x2="38261" y2="38667"/>
-                        <a14:foregroundMark x1="44565" y1="22933" x2="44565" y2="22933"/>
-                        <a14:foregroundMark x1="44783" y1="22933" x2="44783" y2="22933"/>
-                        <a14:foregroundMark x1="49130" y1="15733" x2="49130" y2="15733"/>
-                        <a14:foregroundMark x1="54783" y1="22400" x2="54783" y2="22400"/>
-                        <a14:foregroundMark x1="52935" y1="29600" x2="52935" y2="29600"/>
-                        <a14:foregroundMark x1="38043" y1="29600" x2="38043" y2="29600"/>
-                        <a14:foregroundMark x1="67500" y1="26933" x2="67500" y2="26933"/>
-                        <a14:foregroundMark x1="66739" y1="19733" x2="66739" y2="19733"/>
-                        <a14:foregroundMark x1="88043" y1="16800" x2="88043" y2="16800"/>
-                        <a14:foregroundMark x1="84674" y1="16800" x2="84674" y2="16800"/>
-                        <a14:foregroundMark x1="85326" y1="22933" x2="85326" y2="22933"/>
-                        <a14:foregroundMark x1="90326" y1="24800" x2="90326" y2="24800"/>
-                        <a14:foregroundMark x1="91630" y1="18133" x2="91630" y2="18133"/>
-                        <a14:foregroundMark x1="72174" y1="20267" x2="72174" y2="20267"/>
-                        <a14:foregroundMark x1="72935" y1="25867" x2="72935" y2="25867"/>
-                        <a14:foregroundMark x1="52935" y1="17067" x2="52935" y2="17067"/>
-                        <a14:foregroundMark x1="53696" y1="17067" x2="53696" y2="17067"/>
-                        <a14:foregroundMark x1="38696" y1="24800" x2="38696" y2="24800"/>
-                        <a14:foregroundMark x1="17174" y1="20800" x2="17174" y2="20800"/>
-                        <a14:foregroundMark x1="18152" y1="20800" x2="18152" y2="20800"/>
-                        <a14:foregroundMark x1="18804" y1="17600" x2="18804" y2="17600"/>
-                        <a14:foregroundMark x1="18804" y1="16267" x2="18804" y2="16267"/>
-                        <a14:foregroundMark x1="12717" y1="32000" x2="12717" y2="32000"/>
-                        <a14:foregroundMark x1="12500" y1="13067" x2="12500" y2="13067"/>
-                        <a14:foregroundMark x1="12500" y1="12533" x2="12500" y2="12533"/>
-                        <a14:foregroundMark x1="34457" y1="26400" x2="34457" y2="26400"/>
-                        <a14:foregroundMark x1="49130" y1="22933" x2="49130" y2="22933"/>
-                        <a14:foregroundMark x1="67283" y1="17067" x2="67283" y2="17067"/>
-                        <a14:foregroundMark x1="67283" y1="16800" x2="67283" y2="16800"/>
-                        <a14:foregroundMark x1="67283" y1="16267" x2="67283" y2="16267"/>
-                      </a14:backgroundRemoval>
-                    </a14:imgEffect>
-                  </a14:imgLayer>
-                </a14:imgProps>
-              </a:ext>
-            </a:extLst>
-          </a:blip>
-          <a:stretch>
-            <a:fillRect/>
-          </a:stretch>
-        </p:blipFill>
-        <p:spPr>
-          <a:xfrm>
-            <a:off x="424588" y="5352718"/>
-            <a:ext cx="3037028" cy="1234618"/>
-          </a:xfrm>
-          <a:prstGeom prst="rect">
-            <a:avLst/>
-          </a:prstGeom>
-        </p:spPr>
-      </p:pic>
       <p:sp>
         <p:nvSpPr>
           <p:cNvPr id="4" name="Rectangle 3"/>
@@ -6165,7 +6044,7 @@
         </p:nvSpPr>
         <p:spPr bwMode="auto">
           <a:xfrm>
-            <a:off x="4986337" y="1442885"/>
+            <a:off x="4986337" y="1751495"/>
             <a:ext cx="6682359" cy="3323987"/>
           </a:xfrm>
           <a:prstGeom prst="rect">
@@ -6224,70 +6103,6 @@
           </a:p>
         </p:txBody>
       </p:sp>
-      <p:sp>
-        <p:nvSpPr>
-          <p:cNvPr id="9" name="Rectangle 8">
-            <a:extLst>
-              <a:ext uri="{FF2B5EF4-FFF2-40B4-BE49-F238E27FC236}">
-                <a16:creationId xmlns:a16="http://schemas.microsoft.com/office/drawing/2014/main" id="{71833D9C-3B5B-7E47-89CD-4D008960CA6E}"/>
-              </a:ext>
-            </a:extLst>
-          </p:cNvPr>
-          <p:cNvSpPr>
-            <a:spLocks noChangeArrowheads="1"/>
-          </p:cNvSpPr>
-          <p:nvPr/>
-        </p:nvSpPr>
-        <p:spPr bwMode="auto">
-          <a:xfrm>
-            <a:off x="3469834" y="5459788"/>
-            <a:ext cx="8485079" cy="1015663"/>
-          </a:xfrm>
-          <a:prstGeom prst="rect">
-            <a:avLst/>
-          </a:prstGeom>
-          <a:noFill/>
-          <a:ln w="9525">
-            <a:noFill/>
-            <a:miter lim="800000"/>
-            <a:headEnd/>
-            <a:tailEnd/>
-          </a:ln>
-          <a:effectLst/>
-        </p:spPr>
-        <p:txBody>
-          <a:bodyPr wrap="square">
-            <a:spAutoFit/>
-          </a:bodyPr>
-          <a:lstStyle/>
-          <a:p>
-            <a:pPr>
-              <a:defRPr/>
-            </a:pPr>
-            <a:r>
-              <a:rPr lang="en-US" sz="3000" b="1" dirty="0">
-                <a:latin typeface="Avenir"/>
-                <a:cs typeface="Avenir"/>
-              </a:rPr>
-              <a:t>Ponder on your </a:t>
-            </a:r>
-            <a:r>
-              <a:rPr lang="en-US" sz="3000" b="1">
-                <a:latin typeface="Avenir"/>
-                <a:cs typeface="Avenir"/>
-              </a:rPr>
-              <a:t>own (3 </a:t>
-            </a:r>
-            <a:r>
-              <a:rPr lang="en-US" sz="3000" b="1" dirty="0">
-                <a:latin typeface="Avenir"/>
-                <a:cs typeface="Avenir"/>
-              </a:rPr>
-              <a:t>m), discuss with a partner (5 m), then share with the class (5 m).</a:t>
-            </a:r>
-          </a:p>
-        </p:txBody>
-      </p:sp>
       <p:pic>
         <p:nvPicPr>
           <p:cNvPr id="8" name="Picture 2" descr="04 Feeding in Whip &amp; Hook">
@@ -6303,7 +6118,7 @@
           <p:nvPr/>
         </p:nvPicPr>
         <p:blipFill rotWithShape="1">
-          <a:blip r:embed="rId5">
+          <a:blip r:embed="rId3">
             <a:extLst>
               <a:ext uri="{28A0092B-C50C-407E-A947-70E740481C1C}">
                 <a14:useLocalDpi xmlns:a14="http://schemas.microsoft.com/office/drawing/2010/main" val="0"/>
@@ -6315,7 +6130,7 @@
         </p:blipFill>
         <p:spPr bwMode="auto">
           <a:xfrm>
-            <a:off x="881062" y="1162957"/>
+            <a:off x="881062" y="1471567"/>
             <a:ext cx="3733800" cy="3950373"/>
           </a:xfrm>
           <a:prstGeom prst="rect">
@@ -6327,14 +6142,14 @@
           </a:ln>
           <a:extLst>
             <a:ext uri="{909E8E84-426E-40dd-AFC4-6F175D3DCCD1}">
-              <a14:hiddenFill xmlns:a14="http://schemas.microsoft.com/office/drawing/2010/main" xmlns="">
+              <a14:hiddenFill xmlns="" xmlns:a14="http://schemas.microsoft.com/office/drawing/2010/main">
                 <a:solidFill>
                   <a:srgbClr val="FFFFFF"/>
                 </a:solidFill>
               </a14:hiddenFill>
             </a:ext>
             <a:ext uri="{91240B29-F687-4f45-9708-019B960494DF}">
-              <a14:hiddenLine xmlns:a14="http://schemas.microsoft.com/office/drawing/2010/main" xmlns="" w="9525">
+              <a14:hiddenLine xmlns="" xmlns:a14="http://schemas.microsoft.com/office/drawing/2010/main" w="9525">
                 <a:solidFill>
                   <a:srgbClr val="000000"/>
                 </a:solidFill>
@@ -6344,6 +6159,36 @@
               </a14:hiddenLine>
             </a:ext>
           </a:extLst>
+        </p:spPr>
+      </p:pic>
+      <p:pic>
+        <p:nvPicPr>
+          <p:cNvPr id="2" name="Picture 1">
+            <a:extLst>
+              <a:ext uri="{FF2B5EF4-FFF2-40B4-BE49-F238E27FC236}">
+                <a16:creationId xmlns:a16="http://schemas.microsoft.com/office/drawing/2014/main" id="{DC14F2C6-E562-ECEF-DA27-84EAF961E73D}"/>
+              </a:ext>
+            </a:extLst>
+          </p:cNvPr>
+          <p:cNvPicPr>
+            <a:picLocks noChangeAspect="1"/>
+          </p:cNvPicPr>
+          <p:nvPr/>
+        </p:nvPicPr>
+        <p:blipFill>
+          <a:blip r:embed="rId4"/>
+          <a:stretch>
+            <a:fillRect/>
+          </a:stretch>
+        </p:blipFill>
+        <p:spPr>
+          <a:xfrm>
+            <a:off x="4480284" y="5729064"/>
+            <a:ext cx="3345721" cy="541574"/>
+          </a:xfrm>
+          <a:prstGeom prst="rect">
+            <a:avLst/>
+          </a:prstGeom>
         </p:spPr>
       </p:pic>
     </p:spTree>

</xml_diff>